<commit_message>
feat: ajustes na capa da apresentação e pdf
</commit_message>
<xml_diff>
--- a/projeto_go_cs_forecast_aera-v8.pptx
+++ b/projeto_go_cs_forecast_aera-v8.pptx
@@ -130,35 +130,6 @@
     </p:ext>
   </p:extLst>
 </p:presentation>
-</file>
-
-<file path=ppt/changesInfos/changesInfo1.xml><?xml version="1.0" encoding="utf-8"?>
-<pc:chgInfo xmlns:a="http://schemas.openxmlformats.org/drawingml/2006/main" xmlns:r="http://schemas.openxmlformats.org/officeDocument/2006/relationships" xmlns:ac="http://schemas.microsoft.com/office/drawing/2013/main/command" xmlns:pc="http://schemas.microsoft.com/office/powerpoint/2013/main/command">
-  <pc:docChgLst>
-    <pc:chgData name="André Moreira" userId="a074d5cff11e4feb" providerId="LiveId" clId="{A3AE0FC4-E642-4DAF-99C2-2E02E3CB77AA}"/>
-    <pc:docChg chg="modSld">
-      <pc:chgData name="André Moreira" userId="a074d5cff11e4feb" providerId="LiveId" clId="{A3AE0FC4-E642-4DAF-99C2-2E02E3CB77AA}" dt="2026-10-21T22:01:13.553" v="5" actId="1035"/>
-      <pc:docMkLst>
-        <pc:docMk/>
-      </pc:docMkLst>
-      <pc:sldChg chg="modSp mod">
-        <pc:chgData name="André Moreira" userId="a074d5cff11e4feb" providerId="LiveId" clId="{A3AE0FC4-E642-4DAF-99C2-2E02E3CB77AA}" dt="2026-10-21T22:01:13.553" v="5" actId="1035"/>
-        <pc:sldMkLst>
-          <pc:docMk/>
-          <pc:sldMk cId="0" sldId="263"/>
-        </pc:sldMkLst>
-        <pc:spChg chg="mod">
-          <ac:chgData name="André Moreira" userId="a074d5cff11e4feb" providerId="LiveId" clId="{A3AE0FC4-E642-4DAF-99C2-2E02E3CB77AA}" dt="2026-10-21T22:01:13.553" v="5" actId="1035"/>
-          <ac:spMkLst>
-            <pc:docMk/>
-            <pc:sldMk cId="0" sldId="263"/>
-            <ac:spMk id="6" creationId="{00000000-0000-0000-0000-000000000000}"/>
-          </ac:spMkLst>
-        </pc:spChg>
-      </pc:sldChg>
-    </pc:docChg>
-  </pc:docChgLst>
-</pc:chgInfo>
 </file>
 
 <file path=ppt/notesMasters/notesMaster1.xml><?xml version="1.0" encoding="utf-8"?>
@@ -1173,7 +1144,7 @@
           <a:p>
             <a:fld id="{5BCAD085-E8A6-8845-BD4E-CB4CCA059FC4}" type="datetimeFigureOut">
               <a:rPr lang="en-US" smtClean="0"/>
-              <a:t>10/21/2026</a:t>
+              <a:t>10/22/2026</a:t>
             </a:fld>
             <a:endParaRPr lang="en-US"/>
           </a:p>
@@ -1336,7 +1307,7 @@
           <a:p>
             <a:fld id="{5BCAD085-E8A6-8845-BD4E-CB4CCA059FC4}" type="datetimeFigureOut">
               <a:rPr lang="en-US" smtClean="0"/>
-              <a:t>10/21/2026</a:t>
+              <a:t>10/22/2026</a:t>
             </a:fld>
             <a:endParaRPr lang="en-US"/>
           </a:p>
@@ -1509,7 +1480,7 @@
           <a:p>
             <a:fld id="{5BCAD085-E8A6-8845-BD4E-CB4CCA059FC4}" type="datetimeFigureOut">
               <a:rPr lang="en-US" smtClean="0"/>
-              <a:t>10/21/2026</a:t>
+              <a:t>10/22/2026</a:t>
             </a:fld>
             <a:endParaRPr lang="en-US"/>
           </a:p>
@@ -1672,7 +1643,7 @@
           <a:p>
             <a:fld id="{5BCAD085-E8A6-8845-BD4E-CB4CCA059FC4}" type="datetimeFigureOut">
               <a:rPr lang="en-US" smtClean="0"/>
-              <a:t>10/21/2026</a:t>
+              <a:t>10/22/2026</a:t>
             </a:fld>
             <a:endParaRPr lang="en-US"/>
           </a:p>
@@ -1912,7 +1883,7 @@
           <a:p>
             <a:fld id="{5BCAD085-E8A6-8845-BD4E-CB4CCA059FC4}" type="datetimeFigureOut">
               <a:rPr lang="en-US" smtClean="0"/>
-              <a:t>10/21/2026</a:t>
+              <a:t>10/22/2026</a:t>
             </a:fld>
             <a:endParaRPr lang="en-US"/>
           </a:p>
@@ -2192,7 +2163,7 @@
           <a:p>
             <a:fld id="{5BCAD085-E8A6-8845-BD4E-CB4CCA059FC4}" type="datetimeFigureOut">
               <a:rPr lang="en-US" smtClean="0"/>
-              <a:t>10/21/2026</a:t>
+              <a:t>10/22/2026</a:t>
             </a:fld>
             <a:endParaRPr lang="en-US"/>
           </a:p>
@@ -2606,7 +2577,7 @@
           <a:p>
             <a:fld id="{5BCAD085-E8A6-8845-BD4E-CB4CCA059FC4}" type="datetimeFigureOut">
               <a:rPr lang="en-US" smtClean="0"/>
-              <a:t>10/21/2026</a:t>
+              <a:t>10/22/2026</a:t>
             </a:fld>
             <a:endParaRPr lang="en-US"/>
           </a:p>
@@ -2718,7 +2689,7 @@
           <a:p>
             <a:fld id="{5BCAD085-E8A6-8845-BD4E-CB4CCA059FC4}" type="datetimeFigureOut">
               <a:rPr lang="en-US" smtClean="0"/>
-              <a:t>10/21/2026</a:t>
+              <a:t>10/22/2026</a:t>
             </a:fld>
             <a:endParaRPr lang="en-US"/>
           </a:p>
@@ -2808,7 +2779,7 @@
           <a:p>
             <a:fld id="{5BCAD085-E8A6-8845-BD4E-CB4CCA059FC4}" type="datetimeFigureOut">
               <a:rPr lang="en-US" smtClean="0"/>
-              <a:t>10/21/2026</a:t>
+              <a:t>10/22/2026</a:t>
             </a:fld>
             <a:endParaRPr lang="en-US"/>
           </a:p>
@@ -3078,7 +3049,7 @@
           <a:p>
             <a:fld id="{5BCAD085-E8A6-8845-BD4E-CB4CCA059FC4}" type="datetimeFigureOut">
               <a:rPr lang="en-US" smtClean="0"/>
-              <a:t>10/21/2026</a:t>
+              <a:t>10/22/2026</a:t>
             </a:fld>
             <a:endParaRPr lang="en-US"/>
           </a:p>
@@ -3325,7 +3296,7 @@
           <a:p>
             <a:fld id="{5BCAD085-E8A6-8845-BD4E-CB4CCA059FC4}" type="datetimeFigureOut">
               <a:rPr lang="en-US" smtClean="0"/>
-              <a:t>10/21/2026</a:t>
+              <a:t>10/22/2026</a:t>
             </a:fld>
             <a:endParaRPr lang="en-US"/>
           </a:p>
@@ -3531,7 +3502,7 @@
           <a:p>
             <a:fld id="{5BCAD085-E8A6-8845-BD4E-CB4CCA059FC4}" type="datetimeFigureOut">
               <a:rPr lang="en-US" smtClean="0"/>
-              <a:t>10/21/2026</a:t>
+              <a:t>10/22/2026</a:t>
             </a:fld>
             <a:endParaRPr lang="en-US"/>
           </a:p>
@@ -3987,6 +3958,7 @@
               </a:defRPr>
             </a:pPr>
             <a:r>
+              <a:rPr dirty="0"/>
               <a:t>PROJETO DE GESTÃO DE OPERAÇÕES E CADEIA DE SUPRIMENTOS</a:t>
             </a:r>
           </a:p>
@@ -4003,7 +3975,28 @@
               </a:defRPr>
             </a:pPr>
             <a:r>
-              <a:t>Otimização e Automação do Fluxo de Forecast no Sistema AERA</a:t>
+              <a:rPr dirty="0" err="1"/>
+              <a:t>Otimização</a:t>
+            </a:r>
+            <a:r>
+              <a:rPr dirty="0"/>
+              <a:t> e </a:t>
+            </a:r>
+            <a:r>
+              <a:rPr dirty="0" err="1"/>
+              <a:t>Automação</a:t>
+            </a:r>
+            <a:r>
+              <a:rPr dirty="0"/>
+              <a:t> do </a:t>
+            </a:r>
+            <a:r>
+              <a:rPr dirty="0" err="1"/>
+              <a:t>Fluxo</a:t>
+            </a:r>
+            <a:r>
+              <a:rPr dirty="0"/>
+              <a:t> de Forecast no Sistema AERA</a:t>
             </a:r>
           </a:p>
           <a:p>
@@ -4019,8 +4012,42 @@
               </a:defRPr>
             </a:pPr>
             <a:r>
-              <a:t>Redesenho do Processo de Demanda, Mapeamento AS-IS/TO-BE e Plano de Implantação</a:t>
-            </a:r>
+              <a:rPr dirty="0" err="1"/>
+              <a:t>Redesenho</a:t>
+            </a:r>
+            <a:r>
+              <a:rPr dirty="0"/>
+              <a:t> do </a:t>
+            </a:r>
+            <a:r>
+              <a:rPr dirty="0" err="1"/>
+              <a:t>Processo</a:t>
+            </a:r>
+            <a:r>
+              <a:rPr dirty="0"/>
+              <a:t> de </a:t>
+            </a:r>
+            <a:r>
+              <a:rPr dirty="0" err="1"/>
+              <a:t>Demanda</a:t>
+            </a:r>
+            <a:r>
+              <a:rPr dirty="0"/>
+              <a:t>, </a:t>
+            </a:r>
+            <a:r>
+              <a:rPr dirty="0" err="1"/>
+              <a:t>Mapeamento</a:t>
+            </a:r>
+            <a:r>
+              <a:rPr dirty="0"/>
+              <a:t> AS-IS/TO-BE e Plano de </a:t>
+            </a:r>
+            <a:r>
+              <a:rPr dirty="0" err="1"/>
+              <a:t>Implantação</a:t>
+            </a:r>
+            <a:endParaRPr dirty="0"/>
           </a:p>
           <a:p>
             <a:pPr>
@@ -4032,12 +4059,89 @@
               </a:defRPr>
             </a:pPr>
             <a:r>
-              <a:t>Docentes: Prof. Dr. Alvair Silveira Torres Jr. &amp; Profa. Dra. Marisangela (2026)</a:t>
-            </a:r>
-            <a:br/>
-            <a:r>
-              <a:t>Indústria Farmacêutica — Unidade Brasil &amp; Operações Globais</a:t>
-            </a:r>
+              <a:rPr dirty="0" err="1"/>
+              <a:t>Docente</a:t>
+            </a:r>
+            <a:r>
+              <a:rPr dirty="0"/>
+              <a:t>: </a:t>
+            </a:r>
+            <a:r>
+              <a:rPr dirty="0" err="1"/>
+              <a:t>Profa</a:t>
+            </a:r>
+            <a:r>
+              <a:rPr dirty="0"/>
+              <a:t>. </a:t>
+            </a:r>
+            <a:r>
+              <a:rPr lang="pt-BR" dirty="0" err="1"/>
+              <a:t>Msc</a:t>
+            </a:r>
+            <a:r>
+              <a:rPr dirty="0"/>
+              <a:t> </a:t>
+            </a:r>
+            <a:r>
+              <a:rPr dirty="0" err="1"/>
+              <a:t>Marisangela</a:t>
+            </a:r>
+            <a:r>
+              <a:rPr dirty="0"/>
+              <a:t> </a:t>
+            </a:r>
+            <a:r>
+              <a:rPr lang="pt-BR" dirty="0" err="1"/>
+              <a:t>Csik</a:t>
+            </a:r>
+            <a:br>
+              <a:rPr dirty="0"/>
+            </a:br>
+            <a:r>
+              <a:rPr lang="pt-BR" dirty="0"/>
+              <a:t>Case: </a:t>
+            </a:r>
+            <a:r>
+              <a:rPr dirty="0"/>
+              <a:t>Indústria </a:t>
+            </a:r>
+            <a:r>
+              <a:rPr dirty="0" err="1"/>
+              <a:t>Farmacêutica</a:t>
+            </a:r>
+            <a:r>
+              <a:rPr dirty="0"/>
+              <a:t> — </a:t>
+            </a:r>
+            <a:r>
+              <a:rPr dirty="0" err="1"/>
+              <a:t>Unidade</a:t>
+            </a:r>
+            <a:r>
+              <a:rPr dirty="0"/>
+              <a:t> </a:t>
+            </a:r>
+            <a:r>
+              <a:rPr dirty="0" err="1"/>
+              <a:t>Brasil</a:t>
+            </a:r>
+            <a:r>
+              <a:rPr dirty="0"/>
+              <a:t> &amp; </a:t>
+            </a:r>
+            <a:r>
+              <a:rPr dirty="0" err="1"/>
+              <a:t>Operações</a:t>
+            </a:r>
+            <a:r>
+              <a:rPr dirty="0"/>
+              <a:t> </a:t>
+            </a:r>
+            <a:r>
+              <a:rPr dirty="0" err="1"/>
+              <a:t>Globais</a:t>
+            </a:r>
+            <a:endParaRPr dirty="0"/>
           </a:p>
           <a:p>
             <a:pPr>
@@ -4048,7 +4152,7 @@
                 <a:latin typeface="Verdana" panose="020B0604030504040204"/>
               </a:defRPr>
             </a:pPr>
-            <a:endParaRPr/>
+            <a:endParaRPr dirty="0"/>
           </a:p>
           <a:p>
             <a:pPr>
@@ -4059,7 +4163,7 @@
                 <a:latin typeface="Verdana" panose="020B0604030504040204"/>
               </a:defRPr>
             </a:pPr>
-            <a:endParaRPr/>
+            <a:endParaRPr dirty="0"/>
           </a:p>
           <a:p>
             <a:pPr>
@@ -4071,8 +4175,8 @@
               </a:defRPr>
             </a:pPr>
             <a:r>
-              <a:rPr lang="pt-BR"/>
-              <a:t>Grupo 8</a:t>
+              <a:rPr lang="pt-BR" dirty="0"/>
+              <a:t>Grupo 8:</a:t>
             </a:r>
           </a:p>
           <a:p>
@@ -4085,7 +4189,7 @@
               </a:defRPr>
             </a:pPr>
             <a:r>
-              <a:rPr lang="en-US" altLang="en-US"/>
+              <a:rPr lang="en-US" altLang="en-US" dirty="0"/>
               <a:t>André Luiz da Cruz Moreira</a:t>
             </a:r>
           </a:p>
@@ -4099,7 +4203,7 @@
               </a:defRPr>
             </a:pPr>
             <a:r>
-              <a:rPr lang="en-US" altLang="en-US"/>
+              <a:rPr lang="en-US" altLang="en-US" dirty="0"/>
               <a:t>Lucas Silva do Carmo</a:t>
             </a:r>
           </a:p>
@@ -4113,16 +4217,20 @@
               </a:defRPr>
             </a:pPr>
             <a:r>
-              <a:rPr lang="en-US" altLang="en-US"/>
+              <a:rPr lang="en-US" altLang="en-US" dirty="0"/>
               <a:t>Rafael</a:t>
             </a:r>
             <a:r>
-              <a:rPr lang="pt-BR" altLang="en-US"/>
+              <a:rPr lang="pt-BR" altLang="en-US" dirty="0"/>
               <a:t> </a:t>
             </a:r>
             <a:r>
-              <a:rPr lang="en-US" altLang="en-US"/>
-              <a:t>Eiti Tanaka</a:t>
+              <a:rPr lang="en-US" altLang="en-US" dirty="0" err="1"/>
+              <a:t>Eiti</a:t>
+            </a:r>
+            <a:r>
+              <a:rPr lang="en-US" altLang="en-US" dirty="0"/>
+              <a:t> Tanaka</a:t>
             </a:r>
           </a:p>
           <a:p>
@@ -4135,7 +4243,7 @@
               </a:defRPr>
             </a:pPr>
             <a:r>
-              <a:rPr lang="en-US" altLang="en-US"/>
+              <a:rPr lang="en-US" altLang="en-US" dirty="0"/>
               <a:t>Rômulo Pedro Arrivabene</a:t>
             </a:r>
           </a:p>

</xml_diff>